<commit_message>
docs: regenerate deck with latest generate_deck_v2.py output
Re-run of generate_deck_v2.py produced updated PPTX artifact.

https://claude.ai/code/session_01T8RH97Si1WCgNiqunatrUe
</commit_message>
<xml_diff>
--- a/docs/jboss-ai-monitor-deck.pptx
+++ b/docs/jboss-ai-monitor-deck.pptx
@@ -3213,6 +3213,7 @@
                 <a:solidFill>
                   <a:srgbClr val="FFFFFF"/>
                 </a:solidFill>
+                <a:latin typeface="Calibri"/>
               </a:rPr>
               <a:t>Autonomous JBoss Operations</a:t>
             </a:r>
@@ -3224,6 +3225,7 @@
                 <a:solidFill>
                   <a:srgbClr val="FFFFFF"/>
                 </a:solidFill>
+                <a:latin typeface="Calibri"/>
               </a:rPr>
               <a:t>with Red Hat OpenShift AI</a:t>
             </a:r>
@@ -3258,6 +3260,7 @@
                 <a:solidFill>
                   <a:srgbClr val="EEEEEE"/>
                 </a:solidFill>
+                <a:latin typeface="Calibri"/>
               </a:rPr>
               <a:t>Reducing MTTR and operational cost with an AI-powered monitoring agent</a:t>
             </a:r>
@@ -3292,6 +3295,7 @@
                 <a:solidFill>
                   <a:srgbClr val="595959"/>
                 </a:solidFill>
+                <a:latin typeface="Calibri"/>
               </a:rPr>
               <a:t>Red Hat — Confidential</a:t>
             </a:r>
@@ -3387,6 +3391,7 @@
                 <a:solidFill>
                   <a:srgbClr val="EE0000"/>
                 </a:solidFill>
+                <a:latin typeface="Calibri"/>
               </a:rPr>
               <a:t>Running in Your Environment in Under a Day</a:t>
             </a:r>
@@ -3444,8 +3449,8 @@
         </p:nvSpPr>
         <p:spPr>
           <a:xfrm>
-            <a:off x="640080" y="3200400"/>
-            <a:ext cx="4663440" cy="640080"/>
+            <a:off x="594360" y="3200400"/>
+            <a:ext cx="4754880" cy="640080"/>
           </a:xfrm>
           <a:prstGeom prst="rect">
             <a:avLst/>
@@ -3464,6 +3469,7 @@
                 <a:solidFill>
                   <a:srgbClr val="3C8FF7"/>
                 </a:solidFill>
+                <a:latin typeface="Calibri"/>
               </a:rPr>
               <a:t>PHASE 1 — 2 to 4 hours</a:t>
             </a:r>
@@ -3478,8 +3484,8 @@
         </p:nvSpPr>
         <p:spPr>
           <a:xfrm>
-            <a:off x="640080" y="4023360"/>
-            <a:ext cx="4663440" cy="731520"/>
+            <a:off x="594360" y="4023360"/>
+            <a:ext cx="4754880" cy="822960"/>
           </a:xfrm>
           <a:prstGeom prst="rect">
             <a:avLst/>
@@ -3498,6 +3504,7 @@
                 <a:solidFill>
                   <a:srgbClr val="EE0000"/>
                 </a:solidFill>
+                <a:latin typeface="Calibri"/>
               </a:rPr>
               <a:t>Deploy</a:t>
             </a:r>
@@ -3512,8 +3519,8 @@
         </p:nvSpPr>
         <p:spPr>
           <a:xfrm>
-            <a:off x="640080" y="4846320"/>
-            <a:ext cx="4663440" cy="4114800"/>
+            <a:off x="594360" y="4937760"/>
+            <a:ext cx="4754880" cy="3931920"/>
           </a:xfrm>
           <a:prstGeom prst="rect">
             <a:avLst/>
@@ -3532,6 +3539,7 @@
                 <a:solidFill>
                   <a:srgbClr val="212121"/>
                 </a:solidFill>
+                <a:latin typeface="Calibri"/>
               </a:rPr>
               <a:t>OpenShift manifests, RHOAI endpoint, JIRA configuration</a:t>
             </a:r>
@@ -3589,8 +3597,8 @@
         </p:nvSpPr>
         <p:spPr>
           <a:xfrm>
-            <a:off x="6858000" y="3200400"/>
-            <a:ext cx="4663440" cy="640080"/>
+            <a:off x="6812280" y="3200400"/>
+            <a:ext cx="4754880" cy="640080"/>
           </a:xfrm>
           <a:prstGeom prst="rect">
             <a:avLst/>
@@ -3609,6 +3617,7 @@
                 <a:solidFill>
                   <a:srgbClr val="3C8FF7"/>
                 </a:solidFill>
+                <a:latin typeface="Calibri"/>
               </a:rPr>
               <a:t>PHASE 2 — 1 to 2 hours</a:t>
             </a:r>
@@ -3623,8 +3632,8 @@
         </p:nvSpPr>
         <p:spPr>
           <a:xfrm>
-            <a:off x="6858000" y="4023360"/>
-            <a:ext cx="4663440" cy="731520"/>
+            <a:off x="6812280" y="4023360"/>
+            <a:ext cx="4754880" cy="822960"/>
           </a:xfrm>
           <a:prstGeom prst="rect">
             <a:avLst/>
@@ -3643,6 +3652,7 @@
                 <a:solidFill>
                   <a:srgbClr val="EE0000"/>
                 </a:solidFill>
+                <a:latin typeface="Calibri"/>
               </a:rPr>
               <a:t>Validate</a:t>
             </a:r>
@@ -3657,8 +3667,8 @@
         </p:nvSpPr>
         <p:spPr>
           <a:xfrm>
-            <a:off x="6858000" y="4846320"/>
-            <a:ext cx="4663440" cy="4114800"/>
+            <a:off x="6812280" y="4937760"/>
+            <a:ext cx="4754880" cy="3931920"/>
           </a:xfrm>
           <a:prstGeom prst="rect">
             <a:avLst/>
@@ -3677,6 +3687,7 @@
                 <a:solidFill>
                   <a:srgbClr val="212121"/>
                 </a:solidFill>
+                <a:latin typeface="Calibri"/>
               </a:rPr>
               <a:t>Inject test errors, confirm ticket creation, tune patterns</a:t>
             </a:r>
@@ -3734,8 +3745,8 @@
         </p:nvSpPr>
         <p:spPr>
           <a:xfrm>
-            <a:off x="13075919" y="3200400"/>
-            <a:ext cx="4663440" cy="640080"/>
+            <a:off x="13030200" y="3200400"/>
+            <a:ext cx="4754880" cy="640080"/>
           </a:xfrm>
           <a:prstGeom prst="rect">
             <a:avLst/>
@@ -3754,6 +3765,7 @@
                 <a:solidFill>
                   <a:srgbClr val="FFFFFF"/>
                 </a:solidFill>
+                <a:latin typeface="Calibri"/>
               </a:rPr>
               <a:t>PHASE 3 — Ongoing</a:t>
             </a:r>
@@ -3768,8 +3780,8 @@
         </p:nvSpPr>
         <p:spPr>
           <a:xfrm>
-            <a:off x="13075919" y="4023360"/>
-            <a:ext cx="4663440" cy="731520"/>
+            <a:off x="13030200" y="4023360"/>
+            <a:ext cx="4754880" cy="822960"/>
           </a:xfrm>
           <a:prstGeom prst="rect">
             <a:avLst/>
@@ -3788,6 +3800,7 @@
                 <a:solidFill>
                   <a:srgbClr val="FFFFFF"/>
                 </a:solidFill>
+                <a:latin typeface="Calibri"/>
               </a:rPr>
               <a:t>Expand</a:t>
             </a:r>
@@ -3802,8 +3815,8 @@
         </p:nvSpPr>
         <p:spPr>
           <a:xfrm>
-            <a:off x="13075919" y="4846320"/>
-            <a:ext cx="4663440" cy="4114800"/>
+            <a:off x="13030200" y="4937760"/>
+            <a:ext cx="4754880" cy="3931920"/>
           </a:xfrm>
           <a:prstGeom prst="rect">
             <a:avLst/>
@@ -3822,6 +3835,7 @@
                 <a:solidFill>
                   <a:srgbClr val="FFFFFF"/>
                 </a:solidFill>
+                <a:latin typeface="Calibri"/>
               </a:rPr>
               <a:t>Add namespaces, extend to Quarkus and Spring Boot</a:t>
             </a:r>
@@ -3837,7 +3851,7 @@
         <p:spPr>
           <a:xfrm>
             <a:off x="5760720" y="5486400"/>
-            <a:ext cx="914400" cy="731520"/>
+            <a:ext cx="822960" cy="822960"/>
           </a:xfrm>
           <a:prstGeom prst="rect">
             <a:avLst/>
@@ -3856,6 +3870,7 @@
                 <a:solidFill>
                   <a:srgbClr val="EE0000"/>
                 </a:solidFill>
+                <a:latin typeface="Calibri"/>
               </a:rPr>
               <a:t>→</a:t>
             </a:r>
@@ -3871,7 +3886,7 @@
         <p:spPr>
           <a:xfrm>
             <a:off x="11978640" y="5486400"/>
-            <a:ext cx="914400" cy="731520"/>
+            <a:ext cx="822960" cy="822960"/>
           </a:xfrm>
           <a:prstGeom prst="rect">
             <a:avLst/>
@@ -3890,6 +3905,7 @@
                 <a:solidFill>
                   <a:srgbClr val="EE0000"/>
                 </a:solidFill>
+                <a:latin typeface="Calibri"/>
               </a:rPr>
               <a:t>→</a:t>
             </a:r>
@@ -3905,7 +3921,7 @@
         <p:spPr>
           <a:xfrm>
             <a:off x="914400" y="9418320"/>
-            <a:ext cx="16459200" cy="731520"/>
+            <a:ext cx="16459200" cy="640080"/>
           </a:xfrm>
           <a:prstGeom prst="rect">
             <a:avLst/>
@@ -3924,6 +3940,7 @@
                 <a:solidFill>
                   <a:srgbClr val="595959"/>
                 </a:solidFill>
+                <a:latin typeface="Calibri"/>
               </a:rPr>
               <a:t>No professional services engagement required for initial deployment. Customer owns and operates it.</a:t>
             </a:r>
@@ -4019,6 +4036,7 @@
                 <a:solidFill>
                   <a:srgbClr val="EE0000"/>
                 </a:solidFill>
+                <a:latin typeface="Calibri"/>
               </a:rPr>
               <a:t>Three Ways to Move Forward Today</a:t>
             </a:r>
@@ -4096,6 +4114,7 @@
                 <a:solidFill>
                   <a:srgbClr val="3C8FF7"/>
                 </a:solidFill>
+                <a:latin typeface="Calibri"/>
               </a:rPr>
               <a:t>Option 1 — Proof of Value (1 week)</a:t>
             </a:r>
@@ -4110,8 +4129,8 @@
         </p:nvSpPr>
         <p:spPr>
           <a:xfrm>
-            <a:off x="1554480" y="3520440"/>
-            <a:ext cx="15179040" cy="914400"/>
+            <a:off x="1554480" y="3566160"/>
+            <a:ext cx="15179040" cy="822960"/>
           </a:xfrm>
           <a:prstGeom prst="rect">
             <a:avLst/>
@@ -4130,6 +4149,7 @@
                 <a:solidFill>
                   <a:srgbClr val="212121"/>
                 </a:solidFill>
+                <a:latin typeface="Calibri"/>
               </a:rPr>
               <a:t>Deploy in non-production. Run for one week. Measure MTTR delta vs baseline.</a:t>
             </a:r>
@@ -4207,6 +4227,7 @@
                 <a:solidFill>
                   <a:srgbClr val="3C8FF7"/>
                 </a:solidFill>
+                <a:latin typeface="Calibri"/>
               </a:rPr>
               <a:t>Option 2 — Architecture Workshop (half day)</a:t>
             </a:r>
@@ -4221,8 +4242,8 @@
         </p:nvSpPr>
         <p:spPr>
           <a:xfrm>
-            <a:off x="1554480" y="5715000"/>
-            <a:ext cx="15179040" cy="914400"/>
+            <a:off x="1554480" y="5760720"/>
+            <a:ext cx="15179040" cy="822960"/>
           </a:xfrm>
           <a:prstGeom prst="rect">
             <a:avLst/>
@@ -4241,6 +4262,7 @@
                 <a:solidFill>
                   <a:srgbClr val="212121"/>
                 </a:solidFill>
+                <a:latin typeface="Calibri"/>
               </a:rPr>
               <a:t>Red Hat architect maps the solution to your JBoss topology and RHOAI setup.</a:t>
             </a:r>
@@ -4318,6 +4340,7 @@
                 <a:solidFill>
                   <a:srgbClr val="FFFFFF"/>
                 </a:solidFill>
+                <a:latin typeface="Calibri"/>
               </a:rPr>
               <a:t>Option 3 — Production Deployment</a:t>
             </a:r>
@@ -4332,8 +4355,8 @@
         </p:nvSpPr>
         <p:spPr>
           <a:xfrm>
-            <a:off x="1554480" y="7909560"/>
-            <a:ext cx="15179040" cy="914400"/>
+            <a:off x="1554480" y="7955279"/>
+            <a:ext cx="15179040" cy="822960"/>
           </a:xfrm>
           <a:prstGeom prst="rect">
             <a:avLst/>
@@ -4352,6 +4375,7 @@
                 <a:solidFill>
                   <a:srgbClr val="FFFFFF"/>
                 </a:solidFill>
+                <a:latin typeface="Calibri"/>
               </a:rPr>
               <a:t>Scoped engagement: deploy, configure, and hand over with runbook and training.</a:t>
             </a:r>
@@ -4367,7 +4391,7 @@
         <p:spPr>
           <a:xfrm>
             <a:off x="1371600" y="9326880"/>
-            <a:ext cx="15544800" cy="640080"/>
+            <a:ext cx="15544800" cy="548640"/>
           </a:xfrm>
           <a:prstGeom prst="rect">
             <a:avLst/>
@@ -4386,6 +4410,7 @@
                 <a:solidFill>
                   <a:srgbClr val="595959"/>
                 </a:solidFill>
+                <a:latin typeface="Calibri"/>
               </a:rPr>
               <a:t>All source code is open and customer-owned.</a:t>
             </a:r>
@@ -4524,6 +4549,7 @@
                 <a:solidFill>
                   <a:srgbClr val="FFFFFF"/>
                 </a:solidFill>
+                <a:latin typeface="Calibri"/>
               </a:rPr>
               <a:t>Questions?</a:t>
             </a:r>
@@ -4558,6 +4584,7 @@
                 <a:solidFill>
                   <a:srgbClr val="EEEEEE"/>
                 </a:solidFill>
+                <a:latin typeface="Calibri"/>
               </a:rPr>
               <a:t>Let us talk about your JBoss environment.</a:t>
             </a:r>
@@ -4592,6 +4619,7 @@
                 <a:solidFill>
                   <a:srgbClr val="595959"/>
                 </a:solidFill>
+                <a:latin typeface="Calibri"/>
               </a:rPr>
               <a:t>[Name] · [email] · Red Hat Senior Architect</a:t>
             </a:r>
@@ -4687,6 +4715,7 @@
                 <a:solidFill>
                   <a:srgbClr val="EE0000"/>
                 </a:solidFill>
+                <a:latin typeface="Calibri"/>
               </a:rPr>
               <a:t>The Status Quo: Manual, Reactive, Expensive</a:t>
             </a:r>
@@ -4768,6 +4797,7 @@
                 <a:solidFill>
                   <a:srgbClr val="212121"/>
                 </a:solidFill>
+                <a:latin typeface="Calibri"/>
               </a:rPr>
               <a:t>▶  JBoss incidents go undetected until users complain</a:t>
             </a:r>
@@ -4783,6 +4813,7 @@
                 <a:solidFill>
                   <a:srgbClr val="212121"/>
                 </a:solidFill>
+                <a:latin typeface="Calibri"/>
               </a:rPr>
               <a:t>▶  Senior engineers spend 2+ hours per incident on root cause</a:t>
             </a:r>
@@ -4798,6 +4829,7 @@
                 <a:solidFill>
                   <a:srgbClr val="212121"/>
                 </a:solidFill>
+                <a:latin typeface="Calibri"/>
               </a:rPr>
               <a:t>▶  JIRA tickets created manually — late, incomplete, inconsistent</a:t>
             </a:r>
@@ -4813,6 +4845,7 @@
                 <a:solidFill>
                   <a:srgbClr val="212121"/>
                 </a:solidFill>
+                <a:latin typeface="Calibri"/>
               </a:rPr>
               <a:t>▶  On-call rotations are expensive and cause burnout</a:t>
             </a:r>
@@ -4828,6 +4861,7 @@
                 <a:solidFill>
                   <a:srgbClr val="212121"/>
                 </a:solidFill>
+                <a:latin typeface="Calibri"/>
               </a:rPr>
               <a:t>▶  The same incidents recur — fixes are never documented</a:t>
             </a:r>
@@ -4923,6 +4957,7 @@
                 <a:solidFill>
                   <a:srgbClr val="EE0000"/>
                 </a:solidFill>
+                <a:latin typeface="Calibri"/>
               </a:rPr>
               <a:t>Detect. Analyse. Document. Automatically.</a:t>
             </a:r>
@@ -5023,8 +5058,8 @@
         </p:nvSpPr>
         <p:spPr>
           <a:xfrm>
-            <a:off x="731520" y="3291840"/>
-            <a:ext cx="3383280" cy="1097280"/>
+            <a:off x="548640" y="3291840"/>
+            <a:ext cx="3749039" cy="1097280"/>
           </a:xfrm>
           <a:prstGeom prst="rect">
             <a:avLst/>
@@ -5043,6 +5078,7 @@
                 <a:solidFill>
                   <a:srgbClr val="212121"/>
                 </a:solidFill>
+                <a:latin typeface="Calibri"/>
               </a:rPr>
               <a:t>🔍</a:t>
             </a:r>
@@ -5057,8 +5093,8 @@
         </p:nvSpPr>
         <p:spPr>
           <a:xfrm>
-            <a:off x="640080" y="4572000"/>
-            <a:ext cx="3566160" cy="640080"/>
+            <a:off x="548640" y="4572000"/>
+            <a:ext cx="3749039" cy="640080"/>
           </a:xfrm>
           <a:prstGeom prst="rect">
             <a:avLst/>
@@ -5077,6 +5113,7 @@
                 <a:solidFill>
                   <a:srgbClr val="EE0000"/>
                 </a:solidFill>
+                <a:latin typeface="Calibri"/>
               </a:rPr>
               <a:t>Detect</a:t>
             </a:r>
@@ -5092,25 +5129,26 @@
         <p:spPr>
           <a:xfrm>
             <a:off x="640080" y="5303520"/>
-            <a:ext cx="3566160" cy="3931920"/>
-          </a:xfrm>
-          <a:prstGeom prst="rect">
-            <a:avLst/>
-          </a:prstGeom>
-          <a:noFill/>
-        </p:spPr>
-        <p:txBody>
-          <a:bodyPr wrap="square">
-            <a:spAutoFit/>
-          </a:bodyPr>
-          <a:lstStyle/>
-          <a:p>
-            <a:pPr algn="l"/>
+            <a:ext cx="3566160" cy="3840480"/>
+          </a:xfrm>
+          <a:prstGeom prst="rect">
+            <a:avLst/>
+          </a:prstGeom>
+          <a:noFill/>
+        </p:spPr>
+        <p:txBody>
+          <a:bodyPr wrap="square">
+            <a:spAutoFit/>
+          </a:bodyPr>
+          <a:lstStyle/>
+          <a:p>
+            <a:pPr algn="ctr"/>
             <a:r>
               <a:rPr sz="2200" b="0" i="0">
                 <a:solidFill>
                   <a:srgbClr val="212121"/>
                 </a:solidFill>
+                <a:latin typeface="Calibri"/>
               </a:rPr>
               <a:t>Monitors pod state, logs, alerts and health every 60 seconds</a:t>
             </a:r>
@@ -5211,8 +5249,8 @@
         </p:nvSpPr>
         <p:spPr>
           <a:xfrm>
-            <a:off x="4846320" y="3291840"/>
-            <a:ext cx="3383280" cy="1097280"/>
+            <a:off x="4663440" y="3291840"/>
+            <a:ext cx="3749039" cy="1097280"/>
           </a:xfrm>
           <a:prstGeom prst="rect">
             <a:avLst/>
@@ -5231,6 +5269,7 @@
                 <a:solidFill>
                   <a:srgbClr val="212121"/>
                 </a:solidFill>
+                <a:latin typeface="Calibri"/>
               </a:rPr>
               <a:t>🧠</a:t>
             </a:r>
@@ -5245,8 +5284,8 @@
         </p:nvSpPr>
         <p:spPr>
           <a:xfrm>
-            <a:off x="4754880" y="4572000"/>
-            <a:ext cx="3566160" cy="640080"/>
+            <a:off x="4663440" y="4572000"/>
+            <a:ext cx="3749039" cy="640080"/>
           </a:xfrm>
           <a:prstGeom prst="rect">
             <a:avLst/>
@@ -5265,6 +5304,7 @@
                 <a:solidFill>
                   <a:srgbClr val="EE0000"/>
                 </a:solidFill>
+                <a:latin typeface="Calibri"/>
               </a:rPr>
               <a:t>Analyse</a:t>
             </a:r>
@@ -5280,25 +5320,26 @@
         <p:spPr>
           <a:xfrm>
             <a:off x="4754880" y="5303520"/>
-            <a:ext cx="3566160" cy="3931920"/>
-          </a:xfrm>
-          <a:prstGeom prst="rect">
-            <a:avLst/>
-          </a:prstGeom>
-          <a:noFill/>
-        </p:spPr>
-        <p:txBody>
-          <a:bodyPr wrap="square">
-            <a:spAutoFit/>
-          </a:bodyPr>
-          <a:lstStyle/>
-          <a:p>
-            <a:pPr algn="l"/>
+            <a:ext cx="3566160" cy="3840480"/>
+          </a:xfrm>
+          <a:prstGeom prst="rect">
+            <a:avLst/>
+          </a:prstGeom>
+          <a:noFill/>
+        </p:spPr>
+        <p:txBody>
+          <a:bodyPr wrap="square">
+            <a:spAutoFit/>
+          </a:bodyPr>
+          <a:lstStyle/>
+          <a:p>
+            <a:pPr algn="ctr"/>
             <a:r>
               <a:rPr sz="2200" b="0" i="0">
                 <a:solidFill>
                   <a:srgbClr val="212121"/>
                 </a:solidFill>
+                <a:latin typeface="Calibri"/>
               </a:rPr>
               <a:t>RHOAI-hosted LLM generates root cause and resolution steps</a:t>
             </a:r>
@@ -5399,8 +5440,8 @@
         </p:nvSpPr>
         <p:spPr>
           <a:xfrm>
-            <a:off x="8961120" y="3291840"/>
-            <a:ext cx="3383280" cy="1097280"/>
+            <a:off x="8778240" y="3291840"/>
+            <a:ext cx="3749039" cy="1097280"/>
           </a:xfrm>
           <a:prstGeom prst="rect">
             <a:avLst/>
@@ -5419,6 +5460,7 @@
                 <a:solidFill>
                   <a:srgbClr val="212121"/>
                 </a:solidFill>
+                <a:latin typeface="Calibri"/>
               </a:rPr>
               <a:t>🎫</a:t>
             </a:r>
@@ -5433,8 +5475,8 @@
         </p:nvSpPr>
         <p:spPr>
           <a:xfrm>
-            <a:off x="8869680" y="4572000"/>
-            <a:ext cx="3566160" cy="640080"/>
+            <a:off x="8778240" y="4572000"/>
+            <a:ext cx="3749039" cy="640080"/>
           </a:xfrm>
           <a:prstGeom prst="rect">
             <a:avLst/>
@@ -5453,6 +5495,7 @@
                 <a:solidFill>
                   <a:srgbClr val="EE0000"/>
                 </a:solidFill>
+                <a:latin typeface="Calibri"/>
               </a:rPr>
               <a:t>Document</a:t>
             </a:r>
@@ -5468,25 +5511,26 @@
         <p:spPr>
           <a:xfrm>
             <a:off x="8869680" y="5303520"/>
-            <a:ext cx="3566160" cy="3931920"/>
-          </a:xfrm>
-          <a:prstGeom prst="rect">
-            <a:avLst/>
-          </a:prstGeom>
-          <a:noFill/>
-        </p:spPr>
-        <p:txBody>
-          <a:bodyPr wrap="square">
-            <a:spAutoFit/>
-          </a:bodyPr>
-          <a:lstStyle/>
-          <a:p>
-            <a:pPr algn="l"/>
+            <a:ext cx="3566160" cy="3840480"/>
+          </a:xfrm>
+          <a:prstGeom prst="rect">
+            <a:avLst/>
+          </a:prstGeom>
+          <a:noFill/>
+        </p:spPr>
+        <p:txBody>
+          <a:bodyPr wrap="square">
+            <a:spAutoFit/>
+          </a:bodyPr>
+          <a:lstStyle/>
+          <a:p>
+            <a:pPr algn="ctr"/>
             <a:r>
               <a:rPr sz="2200" b="0" i="0">
                 <a:solidFill>
                   <a:srgbClr val="212121"/>
                 </a:solidFill>
+                <a:latin typeface="Calibri"/>
               </a:rPr>
               <a:t>Structured JIRA ticket created automatically with full context</a:t>
             </a:r>
@@ -5587,8 +5631,8 @@
         </p:nvSpPr>
         <p:spPr>
           <a:xfrm>
-            <a:off x="13075920" y="3291840"/>
-            <a:ext cx="3383280" cy="1097280"/>
+            <a:off x="12893040" y="3291840"/>
+            <a:ext cx="3749039" cy="1097280"/>
           </a:xfrm>
           <a:prstGeom prst="rect">
             <a:avLst/>
@@ -5607,6 +5651,7 @@
                 <a:solidFill>
                   <a:srgbClr val="212121"/>
                 </a:solidFill>
+                <a:latin typeface="Calibri"/>
               </a:rPr>
               <a:t>🔕</a:t>
             </a:r>
@@ -5621,8 +5666,8 @@
         </p:nvSpPr>
         <p:spPr>
           <a:xfrm>
-            <a:off x="12984480" y="4572000"/>
-            <a:ext cx="3566160" cy="640080"/>
+            <a:off x="12893040" y="4572000"/>
+            <a:ext cx="3749039" cy="640080"/>
           </a:xfrm>
           <a:prstGeom prst="rect">
             <a:avLst/>
@@ -5641,6 +5686,7 @@
                 <a:solidFill>
                   <a:srgbClr val="EE0000"/>
                 </a:solidFill>
+                <a:latin typeface="Calibri"/>
               </a:rPr>
               <a:t>Deduplicate</a:t>
             </a:r>
@@ -5656,25 +5702,26 @@
         <p:spPr>
           <a:xfrm>
             <a:off x="12984480" y="5303520"/>
-            <a:ext cx="3566160" cy="3931920"/>
-          </a:xfrm>
-          <a:prstGeom prst="rect">
-            <a:avLst/>
-          </a:prstGeom>
-          <a:noFill/>
-        </p:spPr>
-        <p:txBody>
-          <a:bodyPr wrap="square">
-            <a:spAutoFit/>
-          </a:bodyPr>
-          <a:lstStyle/>
-          <a:p>
-            <a:pPr algn="l"/>
+            <a:ext cx="3566160" cy="3840480"/>
+          </a:xfrm>
+          <a:prstGeom prst="rect">
+            <a:avLst/>
+          </a:prstGeom>
+          <a:noFill/>
+        </p:spPr>
+        <p:txBody>
+          <a:bodyPr wrap="square">
+            <a:spAutoFit/>
+          </a:bodyPr>
+          <a:lstStyle/>
+          <a:p>
+            <a:pPr algn="ctr"/>
             <a:r>
               <a:rPr sz="2200" b="0" i="0">
                 <a:solidFill>
                   <a:srgbClr val="212121"/>
                 </a:solidFill>
+                <a:latin typeface="Calibri"/>
               </a:rPr>
               <a:t>Suppresses repeat tickets within a configurable time window</a:t>
             </a:r>
@@ -5770,6 +5817,7 @@
                 <a:solidFill>
                   <a:srgbClr val="EE0000"/>
                 </a:solidFill>
+                <a:latin typeface="Calibri"/>
               </a:rPr>
               <a:t>2.5 Hours of Senior Engineer Time → 15 Minutes of Review</a:t>
             </a:r>
@@ -5847,6 +5895,7 @@
                 <a:solidFill>
                   <a:srgbClr val="FFFFFF"/>
                 </a:solidFill>
+                <a:latin typeface="Calibri"/>
               </a:rPr>
               <a:t>Step</a:t>
             </a:r>
@@ -5924,6 +5973,7 @@
                 <a:solidFill>
                   <a:srgbClr val="FFFFFF"/>
                 </a:solidFill>
+                <a:latin typeface="Calibri"/>
               </a:rPr>
               <a:t>Before</a:t>
             </a:r>
@@ -6001,6 +6051,7 @@
                 <a:solidFill>
                   <a:srgbClr val="FFFFFF"/>
                 </a:solidFill>
+                <a:latin typeface="Calibri"/>
               </a:rPr>
               <a:t>After</a:t>
             </a:r>
@@ -6078,6 +6129,7 @@
                 <a:solidFill>
                   <a:srgbClr val="FFFFFF"/>
                 </a:solidFill>
+                <a:latin typeface="Calibri"/>
               </a:rPr>
               <a:t>Time Saved</a:t>
             </a:r>
@@ -6155,6 +6207,7 @@
                 <a:solidFill>
                   <a:srgbClr val="212121"/>
                 </a:solidFill>
+                <a:latin typeface="Calibri"/>
               </a:rPr>
               <a:t>Issue detection</a:t>
             </a:r>
@@ -6232,6 +6285,7 @@
                 <a:solidFill>
                   <a:srgbClr val="212121"/>
                 </a:solidFill>
+                <a:latin typeface="Calibri"/>
               </a:rPr>
               <a:t>5–30 min</a:t>
             </a:r>
@@ -6309,6 +6363,7 @@
                 <a:solidFill>
                   <a:srgbClr val="212121"/>
                 </a:solidFill>
+                <a:latin typeface="Calibri"/>
               </a:rPr>
               <a:t>60 seconds</a:t>
             </a:r>
@@ -6386,6 +6441,7 @@
                 <a:solidFill>
                   <a:srgbClr val="212121"/>
                 </a:solidFill>
+                <a:latin typeface="Calibri"/>
               </a:rPr>
               <a:t>~29 min saved</a:t>
             </a:r>
@@ -6463,6 +6519,7 @@
                 <a:solidFill>
                   <a:srgbClr val="212121"/>
                 </a:solidFill>
+                <a:latin typeface="Calibri"/>
               </a:rPr>
               <a:t>Root cause analysis</a:t>
             </a:r>
@@ -6540,6 +6597,7 @@
                 <a:solidFill>
                   <a:srgbClr val="212121"/>
                 </a:solidFill>
+                <a:latin typeface="Calibri"/>
               </a:rPr>
               <a:t>60–120 min</a:t>
             </a:r>
@@ -6617,6 +6675,7 @@
                 <a:solidFill>
                   <a:srgbClr val="212121"/>
                 </a:solidFill>
+                <a:latin typeface="Calibri"/>
               </a:rPr>
               <a:t>AI: 14 seconds</a:t>
             </a:r>
@@ -6694,6 +6753,7 @@
                 <a:solidFill>
                   <a:srgbClr val="212121"/>
                 </a:solidFill>
+                <a:latin typeface="Calibri"/>
               </a:rPr>
               <a:t>~119 min saved</a:t>
             </a:r>
@@ -6771,6 +6831,7 @@
                 <a:solidFill>
                   <a:srgbClr val="212121"/>
                 </a:solidFill>
+                <a:latin typeface="Calibri"/>
               </a:rPr>
               <a:t>JIRA ticket creation</a:t>
             </a:r>
@@ -6848,6 +6909,7 @@
                 <a:solidFill>
                   <a:srgbClr val="212121"/>
                 </a:solidFill>
+                <a:latin typeface="Calibri"/>
               </a:rPr>
               <a:t>10–15 min</a:t>
             </a:r>
@@ -6925,6 +6987,7 @@
                 <a:solidFill>
                   <a:srgbClr val="212121"/>
                 </a:solidFill>
+                <a:latin typeface="Calibri"/>
               </a:rPr>
               <a:t>Automated</a:t>
             </a:r>
@@ -7002,6 +7065,7 @@
                 <a:solidFill>
                   <a:srgbClr val="212121"/>
                 </a:solidFill>
+                <a:latin typeface="Calibri"/>
               </a:rPr>
               <a:t>~13 min saved</a:t>
             </a:r>
@@ -7079,6 +7143,7 @@
                 <a:solidFill>
                   <a:srgbClr val="FFFFFF"/>
                 </a:solidFill>
+                <a:latin typeface="Calibri"/>
               </a:rPr>
               <a:t>TOTAL</a:t>
             </a:r>
@@ -7156,6 +7221,7 @@
                 <a:solidFill>
                   <a:srgbClr val="FFFFFF"/>
                 </a:solidFill>
+                <a:latin typeface="Calibri"/>
               </a:rPr>
               <a:t>~2.5 hours</a:t>
             </a:r>
@@ -7233,6 +7299,7 @@
                 <a:solidFill>
                   <a:srgbClr val="FFFFFF"/>
                 </a:solidFill>
+                <a:latin typeface="Calibri"/>
               </a:rPr>
               <a:t>~15 min review</a:t>
             </a:r>
@@ -7310,6 +7377,7 @@
                 <a:solidFill>
                   <a:srgbClr val="FFFFFF"/>
                 </a:solidFill>
+                <a:latin typeface="Calibri"/>
               </a:rPr>
               <a:t>~2 hours saved</a:t>
             </a:r>
@@ -7367,8 +7435,8 @@
         </p:nvSpPr>
         <p:spPr>
           <a:xfrm>
-            <a:off x="2743200" y="6949440"/>
-            <a:ext cx="12801600" cy="1097280"/>
+            <a:off x="2743200" y="6995160"/>
+            <a:ext cx="12801600" cy="1005840"/>
           </a:xfrm>
           <a:prstGeom prst="rect">
             <a:avLst/>
@@ -7387,6 +7455,7 @@
                 <a:solidFill>
                   <a:srgbClr val="FFFFFF"/>
                 </a:solidFill>
+                <a:latin typeface="Calibri"/>
               </a:rPr>
               <a:t>At $100/hr blended SRE rate → $225 saved per incident</a:t>
             </a:r>
@@ -7482,6 +7551,7 @@
                 <a:solidFill>
                   <a:srgbClr val="EE0000"/>
                 </a:solidFill>
+                <a:latin typeface="Calibri"/>
               </a:rPr>
               <a:t>The Value Scales With Your Environment</a:t>
             </a:r>
@@ -7539,26 +7609,27 @@
         </p:nvSpPr>
         <p:spPr>
           <a:xfrm>
-            <a:off x="640080" y="3474720"/>
-            <a:ext cx="5120640" cy="1371600"/>
-          </a:xfrm>
-          <a:prstGeom prst="rect">
-            <a:avLst/>
-          </a:prstGeom>
-          <a:noFill/>
-        </p:spPr>
-        <p:txBody>
-          <a:bodyPr wrap="square">
-            <a:spAutoFit/>
-          </a:bodyPr>
-          <a:lstStyle/>
-          <a:p>
-            <a:pPr algn="l"/>
+            <a:off x="548640" y="3474720"/>
+            <a:ext cx="5303520" cy="822960"/>
+          </a:xfrm>
+          <a:prstGeom prst="rect">
+            <a:avLst/>
+          </a:prstGeom>
+          <a:noFill/>
+        </p:spPr>
+        <p:txBody>
+          <a:bodyPr wrap="square">
+            <a:spAutoFit/>
+          </a:bodyPr>
+          <a:lstStyle/>
+          <a:p>
+            <a:pPr algn="ctr"/>
             <a:r>
               <a:rPr sz="2400" b="0" i="0">
                 <a:solidFill>
                   <a:srgbClr val="212121"/>
                 </a:solidFill>
+                <a:latin typeface="Calibri"/>
               </a:rPr>
               <a:t>Small — 1 env · 10 incidents/mo</a:t>
             </a:r>
@@ -7573,8 +7644,8 @@
         </p:nvSpPr>
         <p:spPr>
           <a:xfrm>
-            <a:off x="640080" y="5029200"/>
-            <a:ext cx="5120640" cy="1371600"/>
+            <a:off x="548640" y="5029200"/>
+            <a:ext cx="5303520" cy="1097280"/>
           </a:xfrm>
           <a:prstGeom prst="rect">
             <a:avLst/>
@@ -7593,6 +7664,7 @@
                 <a:solidFill>
                   <a:srgbClr val="EE0000"/>
                 </a:solidFill>
+                <a:latin typeface="Calibri"/>
               </a:rPr>
               <a:t>$27,000/yr</a:t>
             </a:r>
@@ -7607,8 +7679,8 @@
         </p:nvSpPr>
         <p:spPr>
           <a:xfrm>
-            <a:off x="640080" y="6583680"/>
-            <a:ext cx="5120640" cy="731520"/>
+            <a:off x="548640" y="6583680"/>
+            <a:ext cx="5303520" cy="731520"/>
           </a:xfrm>
           <a:prstGeom prst="rect">
             <a:avLst/>
@@ -7625,8 +7697,9 @@
             <a:r>
               <a:rPr sz="2000" b="0" i="0">
                 <a:solidFill>
-                  <a:srgbClr val="212121"/>
-                </a:solidFill>
+                  <a:srgbClr val="595959"/>
+                </a:solidFill>
+                <a:latin typeface="Calibri"/>
               </a:rPr>
               <a:t>annual savings</a:t>
             </a:r>
@@ -7684,26 +7757,27 @@
         </p:nvSpPr>
         <p:spPr>
           <a:xfrm>
-            <a:off x="6583680" y="3474720"/>
-            <a:ext cx="5120640" cy="1371600"/>
-          </a:xfrm>
-          <a:prstGeom prst="rect">
-            <a:avLst/>
-          </a:prstGeom>
-          <a:noFill/>
-        </p:spPr>
-        <p:txBody>
-          <a:bodyPr wrap="square">
-            <a:spAutoFit/>
-          </a:bodyPr>
-          <a:lstStyle/>
-          <a:p>
-            <a:pPr algn="l"/>
+            <a:off x="6492240" y="3474720"/>
+            <a:ext cx="5303520" cy="822960"/>
+          </a:xfrm>
+          <a:prstGeom prst="rect">
+            <a:avLst/>
+          </a:prstGeom>
+          <a:noFill/>
+        </p:spPr>
+        <p:txBody>
+          <a:bodyPr wrap="square">
+            <a:spAutoFit/>
+          </a:bodyPr>
+          <a:lstStyle/>
+          <a:p>
+            <a:pPr algn="ctr"/>
             <a:r>
               <a:rPr sz="2400" b="0" i="0">
                 <a:solidFill>
                   <a:srgbClr val="212121"/>
                 </a:solidFill>
+                <a:latin typeface="Calibri"/>
               </a:rPr>
               <a:t>Medium — 3 envs · 30 incidents/mo</a:t>
             </a:r>
@@ -7718,8 +7792,8 @@
         </p:nvSpPr>
         <p:spPr>
           <a:xfrm>
-            <a:off x="6583680" y="5029200"/>
-            <a:ext cx="5120640" cy="1371600"/>
+            <a:off x="6492240" y="5029200"/>
+            <a:ext cx="5303520" cy="1097280"/>
           </a:xfrm>
           <a:prstGeom prst="rect">
             <a:avLst/>
@@ -7738,6 +7812,7 @@
                 <a:solidFill>
                   <a:srgbClr val="EE0000"/>
                 </a:solidFill>
+                <a:latin typeface="Calibri"/>
               </a:rPr>
               <a:t>$81,000/yr</a:t>
             </a:r>
@@ -7752,8 +7827,8 @@
         </p:nvSpPr>
         <p:spPr>
           <a:xfrm>
-            <a:off x="6583680" y="6583680"/>
-            <a:ext cx="5120640" cy="731520"/>
+            <a:off x="6492240" y="6583680"/>
+            <a:ext cx="5303520" cy="731520"/>
           </a:xfrm>
           <a:prstGeom prst="rect">
             <a:avLst/>
@@ -7770,8 +7845,9 @@
             <a:r>
               <a:rPr sz="2000" b="0" i="0">
                 <a:solidFill>
-                  <a:srgbClr val="212121"/>
-                </a:solidFill>
+                  <a:srgbClr val="595959"/>
+                </a:solidFill>
+                <a:latin typeface="Calibri"/>
               </a:rPr>
               <a:t>annual savings</a:t>
             </a:r>
@@ -7829,8 +7905,113 @@
         </p:nvSpPr>
         <p:spPr>
           <a:xfrm>
-            <a:off x="12527280" y="3474720"/>
-            <a:ext cx="5120640" cy="1371600"/>
+            <a:off x="12435840" y="3474720"/>
+            <a:ext cx="5303520" cy="822960"/>
+          </a:xfrm>
+          <a:prstGeom prst="rect">
+            <a:avLst/>
+          </a:prstGeom>
+          <a:noFill/>
+        </p:spPr>
+        <p:txBody>
+          <a:bodyPr wrap="square">
+            <a:spAutoFit/>
+          </a:bodyPr>
+          <a:lstStyle/>
+          <a:p>
+            <a:pPr algn="ctr"/>
+            <a:r>
+              <a:rPr sz="2400" b="0" i="0">
+                <a:solidFill>
+                  <a:srgbClr val="FFFFFF"/>
+                </a:solidFill>
+                <a:latin typeface="Calibri"/>
+              </a:rPr>
+              <a:t>Large — 10 envs · 100 incidents/mo</a:t>
+            </a:r>
+          </a:p>
+        </p:txBody>
+      </p:sp>
+      <p:sp>
+        <p:nvSpPr>
+          <p:cNvPr id="14" name="TextBox 13"/>
+          <p:cNvSpPr txBox="1"/>
+          <p:nvPr/>
+        </p:nvSpPr>
+        <p:spPr>
+          <a:xfrm>
+            <a:off x="12435840" y="5029200"/>
+            <a:ext cx="5303520" cy="1097280"/>
+          </a:xfrm>
+          <a:prstGeom prst="rect">
+            <a:avLst/>
+          </a:prstGeom>
+          <a:noFill/>
+        </p:spPr>
+        <p:txBody>
+          <a:bodyPr wrap="square">
+            <a:spAutoFit/>
+          </a:bodyPr>
+          <a:lstStyle/>
+          <a:p>
+            <a:pPr algn="ctr"/>
+            <a:r>
+              <a:rPr sz="4800" b="1" i="0">
+                <a:solidFill>
+                  <a:srgbClr val="FFFFFF"/>
+                </a:solidFill>
+                <a:latin typeface="Calibri"/>
+              </a:rPr>
+              <a:t>$270,000/yr</a:t>
+            </a:r>
+          </a:p>
+        </p:txBody>
+      </p:sp>
+      <p:sp>
+        <p:nvSpPr>
+          <p:cNvPr id="15" name="TextBox 14"/>
+          <p:cNvSpPr txBox="1"/>
+          <p:nvPr/>
+        </p:nvSpPr>
+        <p:spPr>
+          <a:xfrm>
+            <a:off x="12435840" y="6583680"/>
+            <a:ext cx="5303520" cy="731520"/>
+          </a:xfrm>
+          <a:prstGeom prst="rect">
+            <a:avLst/>
+          </a:prstGeom>
+          <a:noFill/>
+        </p:spPr>
+        <p:txBody>
+          <a:bodyPr wrap="square">
+            <a:spAutoFit/>
+          </a:bodyPr>
+          <a:lstStyle/>
+          <a:p>
+            <a:pPr algn="ctr"/>
+            <a:r>
+              <a:rPr sz="2000" b="0" i="0">
+                <a:solidFill>
+                  <a:srgbClr val="FFFFFF"/>
+                </a:solidFill>
+                <a:latin typeface="Calibri"/>
+              </a:rPr>
+              <a:t>annual savings</a:t>
+            </a:r>
+          </a:p>
+        </p:txBody>
+      </p:sp>
+      <p:sp>
+        <p:nvSpPr>
+          <p:cNvPr id="16" name="TextBox 15"/>
+          <p:cNvSpPr txBox="1"/>
+          <p:nvPr/>
+        </p:nvSpPr>
+        <p:spPr>
+          <a:xfrm>
+            <a:off x="914400" y="9418320"/>
+            <a:ext cx="16459200" cy="640080"/>
           </a:xfrm>
           <a:prstGeom prst="rect">
             <a:avLst/>
@@ -7845,112 +8026,11 @@
           <a:p>
             <a:pPr algn="l"/>
             <a:r>
-              <a:rPr sz="2400" b="0" i="0">
-                <a:solidFill>
-                  <a:srgbClr val="FFFFFF"/>
-                </a:solidFill>
-              </a:rPr>
-              <a:t>Large — 10 envs · 100 incidents/mo</a:t>
-            </a:r>
-          </a:p>
-        </p:txBody>
-      </p:sp>
-      <p:sp>
-        <p:nvSpPr>
-          <p:cNvPr id="14" name="TextBox 13"/>
-          <p:cNvSpPr txBox="1"/>
-          <p:nvPr/>
-        </p:nvSpPr>
-        <p:spPr>
-          <a:xfrm>
-            <a:off x="12527280" y="5029200"/>
-            <a:ext cx="5120640" cy="1371600"/>
-          </a:xfrm>
-          <a:prstGeom prst="rect">
-            <a:avLst/>
-          </a:prstGeom>
-          <a:noFill/>
-        </p:spPr>
-        <p:txBody>
-          <a:bodyPr wrap="square">
-            <a:spAutoFit/>
-          </a:bodyPr>
-          <a:lstStyle/>
-          <a:p>
-            <a:pPr algn="ctr"/>
-            <a:r>
-              <a:rPr sz="4800" b="1" i="0">
-                <a:solidFill>
-                  <a:srgbClr val="FFFFFF"/>
-                </a:solidFill>
-              </a:rPr>
-              <a:t>$270,000/yr</a:t>
-            </a:r>
-          </a:p>
-        </p:txBody>
-      </p:sp>
-      <p:sp>
-        <p:nvSpPr>
-          <p:cNvPr id="15" name="TextBox 14"/>
-          <p:cNvSpPr txBox="1"/>
-          <p:nvPr/>
-        </p:nvSpPr>
-        <p:spPr>
-          <a:xfrm>
-            <a:off x="12527280" y="6583680"/>
-            <a:ext cx="5120640" cy="731520"/>
-          </a:xfrm>
-          <a:prstGeom prst="rect">
-            <a:avLst/>
-          </a:prstGeom>
-          <a:noFill/>
-        </p:spPr>
-        <p:txBody>
-          <a:bodyPr wrap="square">
-            <a:spAutoFit/>
-          </a:bodyPr>
-          <a:lstStyle/>
-          <a:p>
-            <a:pPr algn="ctr"/>
-            <a:r>
-              <a:rPr sz="2000" b="0" i="0">
-                <a:solidFill>
-                  <a:srgbClr val="FFFFFF"/>
-                </a:solidFill>
-              </a:rPr>
-              <a:t>annual savings</a:t>
-            </a:r>
-          </a:p>
-        </p:txBody>
-      </p:sp>
-      <p:sp>
-        <p:nvSpPr>
-          <p:cNvPr id="16" name="TextBox 15"/>
-          <p:cNvSpPr txBox="1"/>
-          <p:nvPr/>
-        </p:nvSpPr>
-        <p:spPr>
-          <a:xfrm>
-            <a:off x="914400" y="9418320"/>
-            <a:ext cx="16459200" cy="731520"/>
-          </a:xfrm>
-          <a:prstGeom prst="rect">
-            <a:avLst/>
-          </a:prstGeom>
-          <a:noFill/>
-        </p:spPr>
-        <p:txBody>
-          <a:bodyPr wrap="square">
-            <a:spAutoFit/>
-          </a:bodyPr>
-          <a:lstStyle/>
-          <a:p>
-            <a:pPr algn="l"/>
-            <a:r>
               <a:rPr sz="1800" b="0" i="1">
                 <a:solidFill>
                   <a:srgbClr val="595959"/>
                 </a:solidFill>
+                <a:latin typeface="Calibri"/>
               </a:rPr>
               <a:t>Conservative estimate — direct engineer time only. Excludes on-call premiums, prevented downtime, and revenue protection.</a:t>
             </a:r>
@@ -8046,6 +8126,7 @@
                 <a:solidFill>
                   <a:srgbClr val="EE0000"/>
                 </a:solidFill>
+                <a:latin typeface="Calibri"/>
               </a:rPr>
               <a:t>24/7 Coverage — Without 3am Pages</a:t>
             </a:r>
@@ -8103,8 +8184,8 @@
         </p:nvSpPr>
         <p:spPr>
           <a:xfrm>
-            <a:off x="1097280" y="2834640"/>
-            <a:ext cx="16093440" cy="3017520"/>
+            <a:off x="1097280" y="2926080"/>
+            <a:ext cx="16093440" cy="2834640"/>
           </a:xfrm>
           <a:prstGeom prst="rect">
             <a:avLst/>
@@ -8123,8 +8204,9 @@
                 <a:solidFill>
                   <a:srgbClr val="FFFFFF"/>
                 </a:solidFill>
-              </a:rPr>
-              <a:t>"The first P1 incident it catches at 3am on a Sunday — without waking anyone — pays for the entire implementation."</a:t>
+                <a:latin typeface="Calibri"/>
+              </a:rPr>
+              <a:t>“The first P1 incident it catches at 3am on a Sunday — without waking anyone — pays for the entire implementation.”</a:t>
             </a:r>
           </a:p>
         </p:txBody>
@@ -8180,8 +8262,8 @@
         </p:nvSpPr>
         <p:spPr>
           <a:xfrm>
-            <a:off x="640080" y="6675120"/>
-            <a:ext cx="4663440" cy="1097280"/>
+            <a:off x="548640" y="6766560"/>
+            <a:ext cx="4846320" cy="1097280"/>
           </a:xfrm>
           <a:prstGeom prst="rect">
             <a:avLst/>
@@ -8200,6 +8282,7 @@
                 <a:solidFill>
                   <a:srgbClr val="EE0000"/>
                 </a:solidFill>
+                <a:latin typeface="Calibri"/>
               </a:rPr>
               <a:t>10–25%</a:t>
             </a:r>
@@ -8215,7 +8298,7 @@
         <p:spPr>
           <a:xfrm>
             <a:off x="640080" y="7955279"/>
-            <a:ext cx="4663440" cy="1371600"/>
+            <a:ext cx="4663440" cy="1463040"/>
           </a:xfrm>
           <a:prstGeom prst="rect">
             <a:avLst/>
@@ -8234,6 +8317,7 @@
                 <a:solidFill>
                   <a:srgbClr val="212121"/>
                 </a:solidFill>
+                <a:latin typeface="Calibri"/>
               </a:rPr>
               <a:t>On-call salary premium eliminated</a:t>
             </a:r>
@@ -8291,8 +8375,8 @@
         </p:nvSpPr>
         <p:spPr>
           <a:xfrm>
-            <a:off x="6858000" y="6675120"/>
-            <a:ext cx="4663440" cy="1097280"/>
+            <a:off x="6766559" y="6766560"/>
+            <a:ext cx="4846320" cy="1097280"/>
           </a:xfrm>
           <a:prstGeom prst="rect">
             <a:avLst/>
@@ -8311,6 +8395,7 @@
                 <a:solidFill>
                   <a:srgbClr val="EE0000"/>
                 </a:solidFill>
+                <a:latin typeface="Calibri"/>
               </a:rPr>
               <a:t>3am</a:t>
             </a:r>
@@ -8326,7 +8411,7 @@
         <p:spPr>
           <a:xfrm>
             <a:off x="6858000" y="7955279"/>
-            <a:ext cx="4663440" cy="1371600"/>
+            <a:ext cx="4663440" cy="1463040"/>
           </a:xfrm>
           <a:prstGeom prst="rect">
             <a:avLst/>
@@ -8345,6 +8430,7 @@
                 <a:solidFill>
                   <a:srgbClr val="212121"/>
                 </a:solidFill>
+                <a:latin typeface="Calibri"/>
               </a:rPr>
               <a:t>Agent works nights, weekends, holidays</a:t>
             </a:r>
@@ -8402,8 +8488,8 @@
         </p:nvSpPr>
         <p:spPr>
           <a:xfrm>
-            <a:off x="12984480" y="6675120"/>
-            <a:ext cx="4663440" cy="1097280"/>
+            <a:off x="12893040" y="6766560"/>
+            <a:ext cx="4846320" cy="1097280"/>
           </a:xfrm>
           <a:prstGeom prst="rect">
             <a:avLst/>
@@ -8422,6 +8508,7 @@
                 <a:solidFill>
                   <a:srgbClr val="EE0000"/>
                 </a:solidFill>
+                <a:latin typeface="Calibri"/>
               </a:rPr>
               <a:t>0 min</a:t>
             </a:r>
@@ -8437,7 +8524,7 @@
         <p:spPr>
           <a:xfrm>
             <a:off x="12984480" y="7955279"/>
-            <a:ext cx="4663440" cy="1371600"/>
+            <a:ext cx="4663440" cy="1463040"/>
           </a:xfrm>
           <a:prstGeom prst="rect">
             <a:avLst/>
@@ -8456,6 +8543,7 @@
                 <a:solidFill>
                   <a:srgbClr val="212121"/>
                 </a:solidFill>
+                <a:latin typeface="Calibri"/>
               </a:rPr>
               <a:t>Time to ticket after issue detection</a:t>
             </a:r>
@@ -8551,6 +8639,7 @@
                 <a:solidFill>
                   <a:srgbClr val="EE0000"/>
                 </a:solidFill>
+                <a:latin typeface="Calibri"/>
               </a:rPr>
               <a:t>Every Incident Gets a Structured, Actionable Ticket</a:t>
             </a:r>
@@ -8628,6 +8717,7 @@
                 <a:solidFill>
                   <a:srgbClr val="FFFFFF"/>
                 </a:solidFill>
+                <a:latin typeface="Calibri"/>
               </a:rPr>
               <a:t>🔴  OOMKilled — jboss-instance-0  |  CRITICAL  |  jboss-production</a:t>
             </a:r>
@@ -8639,6 +8729,7 @@
                 <a:solidFill>
                   <a:srgbClr val="FFFFFF"/>
                 </a:solidFill>
+                <a:latin typeface="Calibri"/>
               </a:rPr>
               <a:t/>
             </a:r>
@@ -8650,6 +8741,7 @@
                 <a:solidFill>
                   <a:srgbClr val="FFFFFF"/>
                 </a:solidFill>
+                <a:latin typeface="Calibri"/>
               </a:rPr>
               <a:t>🧠  Root Cause  (AI — Confidence: HIGH)</a:t>
             </a:r>
@@ -8661,6 +8753,7 @@
                 <a:solidFill>
                   <a:srgbClr val="FFFFFF"/>
                 </a:solidFill>
+                <a:latin typeface="Calibri"/>
               </a:rPr>
               <a:t>JVM heap exhausted. -Xmx setting too low for workload.</a:t>
             </a:r>
@@ -8672,6 +8765,7 @@
                 <a:solidFill>
                   <a:srgbClr val="FFFFFF"/>
                 </a:solidFill>
+                <a:latin typeface="Calibri"/>
               </a:rPr>
               <a:t>Container memory limit: 1536Mi.  Current heap: 256Mi.</a:t>
             </a:r>
@@ -8683,6 +8777,7 @@
                 <a:solidFill>
                   <a:srgbClr val="FFFFFF"/>
                 </a:solidFill>
+                <a:latin typeface="Calibri"/>
               </a:rPr>
               <a:t/>
             </a:r>
@@ -8694,6 +8789,7 @@
                 <a:solidFill>
                   <a:srgbClr val="FFFFFF"/>
                 </a:solidFill>
+                <a:latin typeface="Calibri"/>
               </a:rPr>
               <a:t>🔧  Resolution Steps</a:t>
             </a:r>
@@ -8705,6 +8801,7 @@
                 <a:solidFill>
                   <a:srgbClr val="FFFFFF"/>
                 </a:solidFill>
+                <a:latin typeface="Calibri"/>
               </a:rPr>
               <a:t>  1. Increase -Xmx to 1024m in standalone.xml</a:t>
             </a:r>
@@ -8716,6 +8813,7 @@
                 <a:solidFill>
                   <a:srgbClr val="FFFFFF"/>
                 </a:solidFill>
+                <a:latin typeface="Calibri"/>
               </a:rPr>
               <a:t>  2. Set OpenShift memory limit to 1536Mi</a:t>
             </a:r>
@@ -8727,6 +8825,7 @@
                 <a:solidFill>
                   <a:srgbClr val="FFFFFF"/>
                 </a:solidFill>
+                <a:latin typeface="Calibri"/>
               </a:rPr>
               <a:t>  3. Enable -XX:+HeapDumpOnOutOfMemoryError</a:t>
             </a:r>
@@ -8738,6 +8837,7 @@
                 <a:solidFill>
                   <a:srgbClr val="FFFFFF"/>
                 </a:solidFill>
+                <a:latin typeface="Calibri"/>
               </a:rPr>
               <a:t/>
             </a:r>
@@ -8749,6 +8849,7 @@
                 <a:solidFill>
                   <a:srgbClr val="FFFFFF"/>
                 </a:solidFill>
+                <a:latin typeface="Calibri"/>
               </a:rPr>
               <a:t>🛡️  Prevention Tips</a:t>
             </a:r>
@@ -8760,6 +8861,7 @@
                 <a:solidFill>
                   <a:srgbClr val="FFFFFF"/>
                 </a:solidFill>
+                <a:latin typeface="Calibri"/>
               </a:rPr>
               <a:t>  •  Set JVM heap to 75% of container memory limit</a:t>
             </a:r>
@@ -8771,6 +8873,7 @@
                 <a:solidFill>
                   <a:srgbClr val="FFFFFF"/>
                 </a:solidFill>
+                <a:latin typeface="Calibri"/>
               </a:rPr>
               <a:t>  •  Add readiness probe on /health/ready</a:t>
             </a:r>
@@ -8782,6 +8885,7 @@
                 <a:solidFill>
                   <a:srgbClr val="FFFFFF"/>
                 </a:solidFill>
+                <a:latin typeface="Calibri"/>
               </a:rPr>
               <a:t/>
             </a:r>
@@ -8793,6 +8897,7 @@
                 <a:solidFill>
                   <a:srgbClr val="FFFFFF"/>
                 </a:solidFill>
+                <a:latin typeface="Calibri"/>
               </a:rPr>
               <a:t>📚  References</a:t>
             </a:r>
@@ -8804,6 +8909,7 @@
                 <a:solidFill>
                   <a:srgbClr val="FFFFFF"/>
                 </a:solidFill>
+                <a:latin typeface="Calibri"/>
               </a:rPr>
               <a:t>  •  Red Hat KBase: Tuning JVM for EAP on OpenShift</a:t>
             </a:r>
@@ -8861,8 +8967,8 @@
         </p:nvSpPr>
         <p:spPr>
           <a:xfrm>
-            <a:off x="13716000" y="4114800"/>
-            <a:ext cx="4114800" cy="2743200"/>
+            <a:off x="13716000" y="4206240"/>
+            <a:ext cx="4114800" cy="2560320"/>
           </a:xfrm>
           <a:prstGeom prst="rect">
             <a:avLst/>
@@ -8881,6 +8987,7 @@
                 <a:solidFill>
                   <a:srgbClr val="FFFFFF"/>
                 </a:solidFill>
+                <a:latin typeface="Calibri"/>
               </a:rPr>
               <a:t>Created in</a:t>
             </a:r>
@@ -8892,6 +8999,7 @@
                 <a:solidFill>
                   <a:srgbClr val="FFFFFF"/>
                 </a:solidFill>
+                <a:latin typeface="Calibri"/>
               </a:rPr>
               <a:t>14 seconds</a:t>
             </a:r>
@@ -8903,6 +9011,7 @@
                 <a:solidFill>
                   <a:srgbClr val="FFFFFF"/>
                 </a:solidFill>
+                <a:latin typeface="Calibri"/>
               </a:rPr>
               <a:t>No human</a:t>
             </a:r>
@@ -8914,6 +9023,7 @@
                 <a:solidFill>
                   <a:srgbClr val="FFFFFF"/>
                 </a:solidFill>
+                <a:latin typeface="Calibri"/>
               </a:rPr>
               <a:t>involved</a:t>
             </a:r>
@@ -9009,6 +9119,7 @@
                 <a:solidFill>
                   <a:srgbClr val="EE0000"/>
                 </a:solidFill>
+                <a:latin typeface="Calibri"/>
               </a:rPr>
               <a:t>Runs on Technology You Already Own</a:t>
             </a:r>
@@ -9024,7 +9135,7 @@
         <p:spPr>
           <a:xfrm>
             <a:off x="914400" y="2743200"/>
-            <a:ext cx="4572000" cy="1005840"/>
+            <a:ext cx="5029200" cy="914400"/>
           </a:xfrm>
           <a:prstGeom prst="rect">
             <a:avLst/>
@@ -9067,25 +9178,26 @@
         <p:spPr>
           <a:xfrm>
             <a:off x="1005840" y="2788920"/>
-            <a:ext cx="4389120" cy="914400"/>
-          </a:xfrm>
-          <a:prstGeom prst="rect">
-            <a:avLst/>
-          </a:prstGeom>
-          <a:noFill/>
-        </p:spPr>
-        <p:txBody>
-          <a:bodyPr wrap="square">
-            <a:spAutoFit/>
-          </a:bodyPr>
-          <a:lstStyle/>
-          <a:p>
-            <a:pPr algn="l"/>
+            <a:ext cx="4846320" cy="822960"/>
+          </a:xfrm>
+          <a:prstGeom prst="rect">
+            <a:avLst/>
+          </a:prstGeom>
+          <a:noFill/>
+        </p:spPr>
+        <p:txBody>
+          <a:bodyPr wrap="square">
+            <a:spAutoFit/>
+          </a:bodyPr>
+          <a:lstStyle/>
+          <a:p>
+            <a:pPr algn="ctr"/>
             <a:r>
               <a:rPr sz="2200" b="1" i="0">
                 <a:solidFill>
                   <a:srgbClr val="FFFFFF"/>
                 </a:solidFill>
+                <a:latin typeface="Calibri"/>
               </a:rPr>
               <a:t>Component</a:t>
             </a:r>
@@ -9100,8 +9212,8 @@
         </p:nvSpPr>
         <p:spPr>
           <a:xfrm>
-            <a:off x="5486400" y="2743200"/>
-            <a:ext cx="5029200" cy="1005840"/>
+            <a:off x="6126480" y="2743200"/>
+            <a:ext cx="4389120" cy="914400"/>
           </a:xfrm>
           <a:prstGeom prst="rect">
             <a:avLst/>
@@ -9143,26 +9255,27 @@
         </p:nvSpPr>
         <p:spPr>
           <a:xfrm>
-            <a:off x="5577840" y="2788920"/>
-            <a:ext cx="4846320" cy="914400"/>
-          </a:xfrm>
-          <a:prstGeom prst="rect">
-            <a:avLst/>
-          </a:prstGeom>
-          <a:noFill/>
-        </p:spPr>
-        <p:txBody>
-          <a:bodyPr wrap="square">
-            <a:spAutoFit/>
-          </a:bodyPr>
-          <a:lstStyle/>
-          <a:p>
-            <a:pPr algn="l"/>
+            <a:off x="6217920" y="2788920"/>
+            <a:ext cx="4206240" cy="822960"/>
+          </a:xfrm>
+          <a:prstGeom prst="rect">
+            <a:avLst/>
+          </a:prstGeom>
+          <a:noFill/>
+        </p:spPr>
+        <p:txBody>
+          <a:bodyPr wrap="square">
+            <a:spAutoFit/>
+          </a:bodyPr>
+          <a:lstStyle/>
+          <a:p>
+            <a:pPr algn="ctr"/>
             <a:r>
               <a:rPr sz="2200" b="1" i="0">
                 <a:solidFill>
                   <a:srgbClr val="FFFFFF"/>
                 </a:solidFill>
+                <a:latin typeface="Calibri"/>
               </a:rPr>
               <a:t>Red Hat Product</a:t>
             </a:r>
@@ -9178,7 +9291,7 @@
         <p:spPr>
           <a:xfrm>
             <a:off x="914400" y="3749039"/>
-            <a:ext cx="4572000" cy="1005840"/>
+            <a:ext cx="5029200" cy="914400"/>
           </a:xfrm>
           <a:prstGeom prst="rect">
             <a:avLst/>
@@ -9221,7 +9334,7 @@
         <p:spPr>
           <a:xfrm>
             <a:off x="1005840" y="3794759"/>
-            <a:ext cx="4389120" cy="914400"/>
+            <a:ext cx="4846320" cy="822960"/>
           </a:xfrm>
           <a:prstGeom prst="rect">
             <a:avLst/>
@@ -9240,6 +9353,7 @@
                 <a:solidFill>
                   <a:srgbClr val="212121"/>
                 </a:solidFill>
+                <a:latin typeface="Calibri"/>
               </a:rPr>
               <a:t>JBoss runtime</a:t>
             </a:r>
@@ -9254,8 +9368,8 @@
         </p:nvSpPr>
         <p:spPr>
           <a:xfrm>
-            <a:off x="5486400" y="3749039"/>
-            <a:ext cx="5029200" cy="1005840"/>
+            <a:off x="6126480" y="3749039"/>
+            <a:ext cx="4389120" cy="914400"/>
           </a:xfrm>
           <a:prstGeom prst="rect">
             <a:avLst/>
@@ -9297,8 +9411,8 @@
         </p:nvSpPr>
         <p:spPr>
           <a:xfrm>
-            <a:off x="5577840" y="3794759"/>
-            <a:ext cx="4846320" cy="914400"/>
+            <a:off x="6217920" y="3794759"/>
+            <a:ext cx="4206240" cy="822960"/>
           </a:xfrm>
           <a:prstGeom prst="rect">
             <a:avLst/>
@@ -9317,6 +9431,7 @@
                 <a:solidFill>
                   <a:srgbClr val="212121"/>
                 </a:solidFill>
+                <a:latin typeface="Calibri"/>
               </a:rPr>
               <a:t>Red Hat JBoss EAP / WildFly Operator</a:t>
             </a:r>
@@ -9332,7 +9447,7 @@
         <p:spPr>
           <a:xfrm>
             <a:off x="914400" y="4754879"/>
-            <a:ext cx="4572000" cy="1005840"/>
+            <a:ext cx="5029200" cy="914400"/>
           </a:xfrm>
           <a:prstGeom prst="rect">
             <a:avLst/>
@@ -9375,7 +9490,7 @@
         <p:spPr>
           <a:xfrm>
             <a:off x="1005840" y="4800599"/>
-            <a:ext cx="4389120" cy="914400"/>
+            <a:ext cx="4846320" cy="822960"/>
           </a:xfrm>
           <a:prstGeom prst="rect">
             <a:avLst/>
@@ -9394,6 +9509,7 @@
                 <a:solidFill>
                   <a:srgbClr val="212121"/>
                 </a:solidFill>
+                <a:latin typeface="Calibri"/>
               </a:rPr>
               <a:t>Container platform</a:t>
             </a:r>
@@ -9408,8 +9524,8 @@
         </p:nvSpPr>
         <p:spPr>
           <a:xfrm>
-            <a:off x="5486400" y="4754879"/>
-            <a:ext cx="5029200" cy="1005840"/>
+            <a:off x="6126480" y="4754879"/>
+            <a:ext cx="4389120" cy="914400"/>
           </a:xfrm>
           <a:prstGeom prst="rect">
             <a:avLst/>
@@ -9451,8 +9567,8 @@
         </p:nvSpPr>
         <p:spPr>
           <a:xfrm>
-            <a:off x="5577840" y="4800599"/>
-            <a:ext cx="4846320" cy="914400"/>
+            <a:off x="6217920" y="4800599"/>
+            <a:ext cx="4206240" cy="822960"/>
           </a:xfrm>
           <a:prstGeom prst="rect">
             <a:avLst/>
@@ -9471,6 +9587,7 @@
                 <a:solidFill>
                   <a:srgbClr val="212121"/>
                 </a:solidFill>
+                <a:latin typeface="Calibri"/>
               </a:rPr>
               <a:t>Red Hat OpenShift</a:t>
             </a:r>
@@ -9486,7 +9603,7 @@
         <p:spPr>
           <a:xfrm>
             <a:off x="914400" y="5760720"/>
-            <a:ext cx="4572000" cy="1005840"/>
+            <a:ext cx="5029200" cy="914400"/>
           </a:xfrm>
           <a:prstGeom prst="rect">
             <a:avLst/>
@@ -9529,7 +9646,7 @@
         <p:spPr>
           <a:xfrm>
             <a:off x="1005840" y="5806440"/>
-            <a:ext cx="4389120" cy="914400"/>
+            <a:ext cx="4846320" cy="822960"/>
           </a:xfrm>
           <a:prstGeom prst="rect">
             <a:avLst/>
@@ -9548,6 +9665,7 @@
                 <a:solidFill>
                   <a:srgbClr val="212121"/>
                 </a:solidFill>
+                <a:latin typeface="Calibri"/>
               </a:rPr>
               <a:t>AI inference</a:t>
             </a:r>
@@ -9562,8 +9680,8 @@
         </p:nvSpPr>
         <p:spPr>
           <a:xfrm>
-            <a:off x="5486400" y="5760720"/>
-            <a:ext cx="5029200" cy="1005840"/>
+            <a:off x="6126480" y="5760720"/>
+            <a:ext cx="4389120" cy="914400"/>
           </a:xfrm>
           <a:prstGeom prst="rect">
             <a:avLst/>
@@ -9605,8 +9723,8 @@
         </p:nvSpPr>
         <p:spPr>
           <a:xfrm>
-            <a:off x="5577840" y="5806440"/>
-            <a:ext cx="4846320" cy="914400"/>
+            <a:off x="6217920" y="5806440"/>
+            <a:ext cx="4206240" cy="822960"/>
           </a:xfrm>
           <a:prstGeom prst="rect">
             <a:avLst/>
@@ -9625,6 +9743,7 @@
                 <a:solidFill>
                   <a:srgbClr val="212121"/>
                 </a:solidFill>
+                <a:latin typeface="Calibri"/>
               </a:rPr>
               <a:t>Red Hat OpenShift AI (RHOAI)</a:t>
             </a:r>
@@ -9640,7 +9759,7 @@
         <p:spPr>
           <a:xfrm>
             <a:off x="914400" y="6766560"/>
-            <a:ext cx="4572000" cy="1005840"/>
+            <a:ext cx="5029200" cy="914400"/>
           </a:xfrm>
           <a:prstGeom prst="rect">
             <a:avLst/>
@@ -9683,7 +9802,7 @@
         <p:spPr>
           <a:xfrm>
             <a:off x="1005840" y="6812280"/>
-            <a:ext cx="4389120" cy="914400"/>
+            <a:ext cx="4846320" cy="822960"/>
           </a:xfrm>
           <a:prstGeom prst="rect">
             <a:avLst/>
@@ -9702,6 +9821,7 @@
                 <a:solidFill>
                   <a:srgbClr val="212121"/>
                 </a:solidFill>
+                <a:latin typeface="Calibri"/>
               </a:rPr>
               <a:t>Model serving</a:t>
             </a:r>
@@ -9716,8 +9836,8 @@
         </p:nvSpPr>
         <p:spPr>
           <a:xfrm>
-            <a:off x="5486400" y="6766560"/>
-            <a:ext cx="5029200" cy="1005840"/>
+            <a:off x="6126480" y="6766560"/>
+            <a:ext cx="4389120" cy="914400"/>
           </a:xfrm>
           <a:prstGeom prst="rect">
             <a:avLst/>
@@ -9759,8 +9879,8 @@
         </p:nvSpPr>
         <p:spPr>
           <a:xfrm>
-            <a:off x="5577840" y="6812280"/>
-            <a:ext cx="4846320" cy="914400"/>
+            <a:off x="6217920" y="6812280"/>
+            <a:ext cx="4206240" cy="822960"/>
           </a:xfrm>
           <a:prstGeom prst="rect">
             <a:avLst/>
@@ -9779,6 +9899,7 @@
                 <a:solidFill>
                   <a:srgbClr val="212121"/>
                 </a:solidFill>
+                <a:latin typeface="Calibri"/>
               </a:rPr>
               <a:t>KServe + vLLM on GPU</a:t>
             </a:r>
@@ -9794,7 +9915,7 @@
         <p:spPr>
           <a:xfrm>
             <a:off x="914400" y="7772400"/>
-            <a:ext cx="4572000" cy="1005840"/>
+            <a:ext cx="5029200" cy="914400"/>
           </a:xfrm>
           <a:prstGeom prst="rect">
             <a:avLst/>
@@ -9837,7 +9958,7 @@
         <p:spPr>
           <a:xfrm>
             <a:off x="1005840" y="7818120"/>
-            <a:ext cx="4389120" cy="914400"/>
+            <a:ext cx="4846320" cy="822960"/>
           </a:xfrm>
           <a:prstGeom prst="rect">
             <a:avLst/>
@@ -9856,6 +9977,7 @@
                 <a:solidFill>
                   <a:srgbClr val="212121"/>
                 </a:solidFill>
+                <a:latin typeface="Calibri"/>
               </a:rPr>
               <a:t>Container image</a:t>
             </a:r>
@@ -9870,8 +9992,8 @@
         </p:nvSpPr>
         <p:spPr>
           <a:xfrm>
-            <a:off x="5486400" y="7772400"/>
-            <a:ext cx="5029200" cy="1005840"/>
+            <a:off x="6126480" y="7772400"/>
+            <a:ext cx="4389120" cy="914400"/>
           </a:xfrm>
           <a:prstGeom prst="rect">
             <a:avLst/>
@@ -9913,8 +10035,8 @@
         </p:nvSpPr>
         <p:spPr>
           <a:xfrm>
-            <a:off x="5577840" y="7818120"/>
-            <a:ext cx="4846320" cy="914400"/>
+            <a:off x="6217920" y="7818120"/>
+            <a:ext cx="4206240" cy="822960"/>
           </a:xfrm>
           <a:prstGeom prst="rect">
             <a:avLst/>
@@ -9933,6 +10055,7 @@
                 <a:solidFill>
                   <a:srgbClr val="212121"/>
                 </a:solidFill>
+                <a:latin typeface="Calibri"/>
               </a:rPr>
               <a:t>UBI9 (Universal Base Image)</a:t>
             </a:r>
@@ -10010,6 +10133,7 @@
                 <a:solidFill>
                   <a:srgbClr val="FFFFFF"/>
                 </a:solidFill>
+                <a:latin typeface="Calibri"/>
               </a:rPr>
               <a:t>✓  Activates your RHOAI investment on Day 1</a:t>
             </a:r>
@@ -10087,6 +10211,7 @@
                 <a:solidFill>
                   <a:srgbClr val="FFFFFF"/>
                 </a:solidFill>
+                <a:latin typeface="Calibri"/>
               </a:rPr>
               <a:t>✓  No new vendor relationship</a:t>
             </a:r>
@@ -10164,6 +10289,7 @@
                 <a:solidFill>
                   <a:srgbClr val="FFFFFF"/>
                 </a:solidFill>
+                <a:latin typeface="Calibri"/>
               </a:rPr>
               <a:t>✓  Customer data never leaves the cluster</a:t>
             </a:r>
@@ -10259,6 +10385,7 @@
                 <a:solidFill>
                   <a:srgbClr val="EE0000"/>
                 </a:solidFill>
+                <a:latin typeface="Calibri"/>
               </a:rPr>
               <a:t>No Generic APM Tool Does This</a:t>
             </a:r>
@@ -10336,6 +10463,7 @@
                 <a:solidFill>
                   <a:srgbClr val="FFFFFF"/>
                 </a:solidFill>
+                <a:latin typeface="Calibri"/>
               </a:rPr>
               <a:t>Capability</a:t>
             </a:r>
@@ -10413,6 +10541,7 @@
                 <a:solidFill>
                   <a:srgbClr val="FFFFFF"/>
                 </a:solidFill>
+                <a:latin typeface="Calibri"/>
               </a:rPr>
               <a:t>Generic APM</a:t>
             </a:r>
@@ -10490,6 +10619,7 @@
                 <a:solidFill>
                   <a:srgbClr val="FFFFFF"/>
                 </a:solidFill>
+                <a:latin typeface="Calibri"/>
               </a:rPr>
               <a:t>Cloud AI Services</a:t>
             </a:r>
@@ -10567,6 +10697,7 @@
                 <a:solidFill>
                   <a:srgbClr val="FFFFFF"/>
                 </a:solidFill>
+                <a:latin typeface="Calibri"/>
               </a:rPr>
               <a:t>This Solution</a:t>
             </a:r>
@@ -10644,6 +10775,7 @@
                 <a:solidFill>
                   <a:srgbClr val="212121"/>
                 </a:solidFill>
+                <a:latin typeface="Calibri"/>
               </a:rPr>
               <a:t>JBoss-specific root cause</a:t>
             </a:r>
@@ -10721,6 +10853,7 @@
                 <a:solidFill>
                   <a:srgbClr val="595959"/>
                 </a:solidFill>
+                <a:latin typeface="Calibri"/>
               </a:rPr>
               <a:t>✗</a:t>
             </a:r>
@@ -10798,6 +10931,7 @@
                 <a:solidFill>
                   <a:srgbClr val="212121"/>
                 </a:solidFill>
+                <a:latin typeface="Calibri"/>
               </a:rPr>
               <a:t>Partial</a:t>
             </a:r>
@@ -10875,6 +11009,7 @@
                 <a:solidFill>
                   <a:srgbClr val="3E8C35"/>
                 </a:solidFill>
+                <a:latin typeface="Calibri"/>
               </a:rPr>
               <a:t>✓</a:t>
             </a:r>
@@ -10952,6 +11087,7 @@
                 <a:solidFill>
                   <a:srgbClr val="212121"/>
                 </a:solidFill>
+                <a:latin typeface="Calibri"/>
               </a:rPr>
               <a:t>AI resolution steps</a:t>
             </a:r>
@@ -11029,6 +11165,7 @@
                 <a:solidFill>
                   <a:srgbClr val="595959"/>
                 </a:solidFill>
+                <a:latin typeface="Calibri"/>
               </a:rPr>
               <a:t>✗</a:t>
             </a:r>
@@ -11106,6 +11243,7 @@
                 <a:solidFill>
                   <a:srgbClr val="595959"/>
                 </a:solidFill>
+                <a:latin typeface="Calibri"/>
               </a:rPr>
               <a:t>✗</a:t>
             </a:r>
@@ -11183,6 +11321,7 @@
                 <a:solidFill>
                   <a:srgbClr val="3E8C35"/>
                 </a:solidFill>
+                <a:latin typeface="Calibri"/>
               </a:rPr>
               <a:t>✓</a:t>
             </a:r>
@@ -11260,6 +11399,7 @@
                 <a:solidFill>
                   <a:srgbClr val="212121"/>
                 </a:solidFill>
+                <a:latin typeface="Calibri"/>
               </a:rPr>
               <a:t>On-premises LLM (no data leaves cluster)</a:t>
             </a:r>
@@ -11337,6 +11477,7 @@
                 <a:solidFill>
                   <a:srgbClr val="595959"/>
                 </a:solidFill>
+                <a:latin typeface="Calibri"/>
               </a:rPr>
               <a:t>✗</a:t>
             </a:r>
@@ -11414,6 +11555,7 @@
                 <a:solidFill>
                   <a:srgbClr val="595959"/>
                 </a:solidFill>
+                <a:latin typeface="Calibri"/>
               </a:rPr>
               <a:t>✗</a:t>
             </a:r>
@@ -11491,6 +11633,7 @@
                 <a:solidFill>
                   <a:srgbClr val="3E8C35"/>
                 </a:solidFill>
+                <a:latin typeface="Calibri"/>
               </a:rPr>
               <a:t>✓</a:t>
             </a:r>
@@ -11568,6 +11711,7 @@
                 <a:solidFill>
                   <a:srgbClr val="212121"/>
                 </a:solidFill>
+                <a:latin typeface="Calibri"/>
               </a:rPr>
               <a:t>Structured JIRA tickets</a:t>
             </a:r>
@@ -11645,6 +11789,7 @@
                 <a:solidFill>
                   <a:srgbClr val="595959"/>
                 </a:solidFill>
+                <a:latin typeface="Calibri"/>
               </a:rPr>
               <a:t>✗</a:t>
             </a:r>
@@ -11722,6 +11867,7 @@
                 <a:solidFill>
                   <a:srgbClr val="595959"/>
                 </a:solidFill>
+                <a:latin typeface="Calibri"/>
               </a:rPr>
               <a:t>✗</a:t>
             </a:r>
@@ -11799,6 +11945,7 @@
                 <a:solidFill>
                   <a:srgbClr val="3E8C35"/>
                 </a:solidFill>
+                <a:latin typeface="Calibri"/>
               </a:rPr>
               <a:t>✓</a:t>
             </a:r>
@@ -11876,6 +12023,7 @@
                 <a:solidFill>
                   <a:srgbClr val="212121"/>
                 </a:solidFill>
+                <a:latin typeface="Calibri"/>
               </a:rPr>
               <a:t>No per-API-call cost</a:t>
             </a:r>
@@ -11953,6 +12101,7 @@
                 <a:solidFill>
                   <a:srgbClr val="212121"/>
                 </a:solidFill>
+                <a:latin typeface="Calibri"/>
               </a:rPr>
               <a:t>—</a:t>
             </a:r>
@@ -12030,6 +12179,7 @@
                 <a:solidFill>
                   <a:srgbClr val="595959"/>
                 </a:solidFill>
+                <a:latin typeface="Calibri"/>
               </a:rPr>
               <a:t>✗</a:t>
             </a:r>
@@ -12107,6 +12257,7 @@
                 <a:solidFill>
                   <a:srgbClr val="3E8C35"/>
                 </a:solidFill>
+                <a:latin typeface="Calibri"/>
               </a:rPr>
               <a:t>✓</a:t>
             </a:r>
@@ -12184,6 +12335,7 @@
                 <a:solidFill>
                   <a:srgbClr val="212121"/>
                 </a:solidFill>
+                <a:latin typeface="Calibri"/>
               </a:rPr>
               <a:t>OpenShift-native</a:t>
             </a:r>
@@ -12261,6 +12413,7 @@
                 <a:solidFill>
                   <a:srgbClr val="595959"/>
                 </a:solidFill>
+                <a:latin typeface="Calibri"/>
               </a:rPr>
               <a:t>✗</a:t>
             </a:r>
@@ -12338,6 +12491,7 @@
                 <a:solidFill>
                   <a:srgbClr val="595959"/>
                 </a:solidFill>
+                <a:latin typeface="Calibri"/>
               </a:rPr>
               <a:t>✗</a:t>
             </a:r>
@@ -12415,6 +12569,7 @@
                 <a:solidFill>
                   <a:srgbClr val="3E8C35"/>
                 </a:solidFill>
+                <a:latin typeface="Calibri"/>
               </a:rPr>
               <a:t>✓</a:t>
             </a:r>

</xml_diff>